<commit_message>
Update the passing-test count on slide 10 and in the certification report (1,240)
The quota manager and epoch gate added 38 tests (1,202 -> 1,240 passed, 5 skipped, 0 failed). The slide audit
compares slide 10 with the junit count and passes again (64 PASS, 0 FAIL); the report's verdict line states both
numbers. No result, draft number or slide claim other than this footer changed.

Co-Authored-By: Claude Sonnet 5.5 <noreply@anthropic.com>
</commit_message>
<xml_diff>
--- a/Seed-Dependent Verdicts — Instructor Briefing.pptx
+++ b/Seed-Dependent Verdicts — Instructor Briefing.pptx
@@ -2305,6 +2305,10 @@
           </a:solidFill>
           <a:ln/>
         </p:spPr>
+        <p:txBody>
+          <a:bodyPr/>
+          <a:p/>
+        </p:txBody>
       </p:sp>
       <p:pic>
         <p:nvPicPr>
@@ -2438,6 +2442,10 @@
           </a:solidFill>
           <a:ln/>
         </p:spPr>
+        <p:txBody>
+          <a:bodyPr/>
+          <a:p/>
+        </p:txBody>
       </p:sp>
       <p:pic>
         <p:nvPicPr>
@@ -2571,6 +2579,10 @@
           </a:solidFill>
           <a:ln/>
         </p:spPr>
+        <p:txBody>
+          <a:bodyPr/>
+          <a:p/>
+        </p:txBody>
       </p:sp>
       <p:pic>
         <p:nvPicPr>
@@ -2704,6 +2716,10 @@
           </a:solidFill>
           <a:ln/>
         </p:spPr>
+        <p:txBody>
+          <a:bodyPr/>
+          <a:p/>
+        </p:txBody>
       </p:sp>
       <p:pic>
         <p:nvPicPr>
@@ -2810,7 +2826,7 @@
                 <a:ea typeface="IBM Plex Sans" pitchFamily="34" charset="-122"/>
                 <a:cs typeface="IBM Plex Sans" pitchFamily="34" charset="-120"/>
               </a:rPr>
-              <a:t>84 trained models · 1,202 passing tests · 986 numbers in the draft machine-checked against their source files, 0 failures</a:t>
+              <a:t>84 trained models · 1,240 passing tests · 986 numbers in the draft machine-checked against their source files, 0 failures</a:t>
             </a:r>
             <a:endParaRPr lang="en-US" sz="1200" dirty="0"/>
           </a:p>
@@ -2881,6 +2897,10 @@
           </a:solidFill>
           <a:ln/>
         </p:spPr>
+        <p:txBody>
+          <a:bodyPr/>
+          <a:p/>
+        </p:txBody>
       </p:sp>
       <p:pic>
         <p:nvPicPr>
@@ -3015,6 +3035,10 @@
           </a:solidFill>
           <a:ln/>
         </p:spPr>
+        <p:txBody>
+          <a:bodyPr/>
+          <a:p/>
+        </p:txBody>
       </p:sp>
       <p:pic>
         <p:nvPicPr>

</xml_diff>